<commit_message>
fix(audio): play bundled Kannada recordings instead of silent browser TTS
- Generate 290 kn-IN neural-voice MP3s for every speakable line and map them by text.
- Prefer recordings in speak(); keep browser TTS as a transliteration-speaking fallback.
- Enable all speaker controls from bundled audio; clarify status messages.
- Fix Chrome cancel/speak race with deferred speak, resume and a watchdog.
- Precache hashed assets + audio in the service worker, ignore Vary: Origin for same-origin static files, and only fall back to index.html for navigations.
- Add post-build asset-precache generator and wire it into npm run build.
- Update docs, deck, PDF and narrated demo video to match the real behaviour.
- Tests: 83 passed; real Chromium verifies online and offline speaker playback.
</commit_message>
<xml_diff>
--- a/docs/Kannada-Saathi-Hackathon-Presentation.pptx
+++ b/docs/Kannada-Saathi-Hackathon-Presentation.pptx
@@ -3802,7 +3802,7 @@
                 </a:solidFill>
                 <a:latin typeface="Calibri"/>
               </a:rPr>
-              <a:t>React 18 · TypeScript strict · Vite · Tailwind · Web Speech APIs · localStorage · 80 passing tests</a:t>
+              <a:t>React 18 · TypeScript strict · Vite 8 · Tailwind · 290 bundled Kannada recordings · 83 passing tests</a:t>
             </a:r>
           </a:p>
         </p:txBody>
@@ -4084,7 +4084,7 @@
                 </a:solidFill>
                 <a:latin typeface="Calibri"/>
               </a:rPr>
-              <a:t>React 18 · TypeScript 5.6 strict · Vite 5 · Tailwind CSS 3 · lucide-react</a:t>
+              <a:t>React 18 · TypeScript 5.6 strict · Vite 8.3.5 · Tailwind CSS 3 · lucide-react</a:t>
             </a:r>
           </a:p>
         </p:txBody>
@@ -4157,7 +4157,7 @@
                 </a:solidFill>
                 <a:latin typeface="Calibri"/>
               </a:rPr>
-              <a:t>react-router-dom 6 with HashRouter → zero rewrite rules on any static host, deep links survive refresh</a:t>
+              <a:t>react-router-dom 7.18.4 with HashRouter → zero rewrite rules on any static host, deep links survive refresh</a:t>
             </a:r>
           </a:p>
         </p:txBody>
@@ -4303,7 +4303,7 @@
                 </a:solidFill>
                 <a:latin typeface="Calibri"/>
               </a:rPr>
-              <a:t>Web Speech APIs: speechSynthesis + SpeechRecognition(kn-IN), behind a capability detector with typed failures</a:t>
+              <a:t>290 bundled Kannada MP3s (kn-IN neural voice) + Web Speech APIs as fallback, behind a capability detector with typed failures</a:t>
             </a:r>
           </a:p>
         </p:txBody>
@@ -4449,7 +4449,7 @@
                 </a:solidFill>
                 <a:latin typeface="Calibri"/>
               </a:rPr>
-              <a:t>Vitest + Testing Library + jsdom: 7 files / 80 tests, including dataset-integrity tests; CI gates the Pages deploy</a:t>
+              <a:t>Vitest 4 + Testing Library + jsdom: 7 files / 83 tests, including dataset-integrity and audio-coverage tests; CI gates the Pages deploy</a:t>
             </a:r>
           </a:p>
         </p:txBody>
@@ -5054,7 +5054,7 @@
                 </a:solidFill>
                 <a:latin typeface="Calibri"/>
               </a:rPr>
-              <a:t>Web Speech API (browser)  ·  data/phrases.ts etc.  ·  optional VITE_AI_PROXY_URL</a:t>
+              <a:t>290 bundled MP3s  ·  Web Speech API fallback  ·  data/phrases.ts etc.  ·  optional VITE_AI_PROXY_URL</a:t>
             </a:r>
           </a:p>
         </p:txBody>
@@ -5816,7 +5816,7 @@
                 </a:solidFill>
                 <a:latin typeface="Calibri"/>
               </a:rPr>
-              <a:t>7 files / 80 tests — dataset shape, script purity (no other Indic or CJK glyphs inside a Kannada field), conversation graph reachability, quiz answer validity, deterministic seeded rounds, storage hydration, search ranking, component behaviour, favourites after remount.</a:t>
+              <a:t>7 files / 83 tests — dataset shape, script purity (no other Indic or CJK glyphs inside a Kannada field), conversation graph reachability, quiz answer validity, deterministic seeded rounds, storage hydration, search ranking, component behaviour, bundled-audio coverage, favourites after remount.</a:t>
             </a:r>
           </a:p>
         </p:txBody>
@@ -5858,7 +5858,7 @@
                 </a:solidFill>
                 <a:latin typeface="Calibri"/>
               </a:rPr>
-              <a:t>Known limits stated in the README: desktop Kannada TTS is rare; recognition is network-backed; clipboard/mic need a secure context; 111 phrases is a starter set, not a dictionary.</a:t>
+              <a:t>Known limits stated in the README: recognition is network-backed; clipboard/mic need a secure context; 111 phrases is a starter set, not a dictionary. Playback no longer needs a system TTS voice.</a:t>
             </a:r>
           </a:p>
         </p:txBody>
@@ -6419,7 +6419,7 @@
                 </a:solidFill>
                 <a:latin typeface="Calibri"/>
               </a:rPr>
-              <a:t> — no kn-IN TTS on most desktops; recognition is Chrome/network-backed — fallbacks cover both</a:t>
+              <a:t> — recognition is Chrome/network-backed; bundled recordings remove the need for a system kn-IN TTS voice</a:t>
             </a:r>
           </a:p>
           <a:p>
@@ -10129,7 +10129,7 @@
                 </a:solidFill>
                 <a:latin typeface="Calibri"/>
               </a:rPr>
-              <a:t>8 situation cards → 111 reviewed phrases. Script + transliteration + meaning + when-to-use + audio + copy + bookmark.</a:t>
+              <a:t>8 situation cards → 111 reviewed phrases. Script + transliteration + meaning + when-to-use + bundled Kannada audio + copy + bookmark.</a:t>
             </a:r>
           </a:p>
         </p:txBody>
@@ -10212,7 +10212,7 @@
                 </a:solidFill>
                 <a:latin typeface="Calibri"/>
               </a:rPr>
-              <a:t>kn-IN recognition where supported, typed fallback, capability dashboard that states what the browser can do. Text-similarity feedback — never a fake accent score.</a:t>
+              <a:t>Bundled Kannada recording for every target, kn-IN recognition where supported, typed fallback, capability dashboard. Text-similarity feedback — never a fake accent score.</a:t>
             </a:r>
           </a:p>
         </p:txBody>
@@ -11012,7 +11012,7 @@
                 </a:solidFill>
                 <a:latin typeface="Calibri"/>
               </a:rPr>
-              <a:t>The app tells you when your browser has no Kannada voice or no recognition, and hands you the typed fallback. It refuses to display a pronunciation score it cannot compute.</a:t>
+              <a:t>The app plays a real bundled Kannada recording even when the browser has no kn-IN voice, reports recognition gaps honestly, and refuses to display a pronunciation score it cannot compute.</a:t>
             </a:r>
           </a:p>
         </p:txBody>
@@ -11178,7 +11178,7 @@
                 </a:solidFill>
                 <a:latin typeface="Calibri"/>
               </a:rPr>
-              <a:t>No backend, no key, no runtime fetch. Every phrase carries a review status, so a native speaker can audit and fix the dataset in one file.</a:t>
+              <a:t>No backend, no key, no third-party/API fetch (audio is bundled). Every phrase carries a review status, so a native speaker can audit and fix the dataset in one file.</a:t>
             </a:r>
           </a:p>
         </p:txBody>
@@ -13513,8 +13513,8 @@
         </p:blipFill>
         <p:spPr>
           <a:xfrm>
-            <a:off x="787908" y="1572768"/>
-            <a:ext cx="3169920" cy="1783080"/>
+            <a:off x="1104900" y="1572768"/>
+            <a:ext cx="2535936" cy="1783080"/>
           </a:xfrm>
           <a:prstGeom prst="rect">
             <a:avLst/>
@@ -13627,8 +13627,8 @@
         </p:blipFill>
         <p:spPr>
           <a:xfrm>
-            <a:off x="5324794" y="1572768"/>
-            <a:ext cx="1649091" cy="1783080"/>
+            <a:off x="4881372" y="1572768"/>
+            <a:ext cx="2535936" cy="1783080"/>
           </a:xfrm>
           <a:prstGeom prst="rect">
             <a:avLst/>
@@ -13741,8 +13741,8 @@
         </p:blipFill>
         <p:spPr>
           <a:xfrm>
-            <a:off x="8866228" y="1572768"/>
-            <a:ext cx="2119166" cy="1783080"/>
+            <a:off x="8657843" y="1572768"/>
+            <a:ext cx="2535936" cy="1783080"/>
           </a:xfrm>
           <a:prstGeom prst="rect">
             <a:avLst/>
@@ -13855,8 +13855,8 @@
         </p:blipFill>
         <p:spPr>
           <a:xfrm>
-            <a:off x="1508344" y="3922776"/>
-            <a:ext cx="1729047" cy="1783080"/>
+            <a:off x="1104900" y="3922776"/>
+            <a:ext cx="2535936" cy="1783080"/>
           </a:xfrm>
           <a:prstGeom prst="rect">
             <a:avLst/>
@@ -13969,8 +13969,8 @@
         </p:blipFill>
         <p:spPr>
           <a:xfrm>
-            <a:off x="5352988" y="3922776"/>
-            <a:ext cx="1592702" cy="1783080"/>
+            <a:off x="4881372" y="3922776"/>
+            <a:ext cx="2535936" cy="1783080"/>
           </a:xfrm>
           <a:prstGeom prst="rect">
             <a:avLst/>
@@ -14083,8 +14083,8 @@
         </p:blipFill>
         <p:spPr>
           <a:xfrm>
-            <a:off x="9513844" y="3922776"/>
-            <a:ext cx="823935" cy="1783080"/>
+            <a:off x="9855270" y="3922776"/>
+            <a:ext cx="141083" cy="1783080"/>
           </a:xfrm>
           <a:prstGeom prst="rect">
             <a:avLst/>
@@ -14170,7 +14170,7 @@
                 </a:solidFill>
                 <a:latin typeface="Calibri"/>
               </a:rPr>
-              <a:t>Same build the judges get: npm install &amp;&amp; npm run dev → localhost:5173 · tsc and 80 tests green on this commit.</a:t>
+              <a:t>Same build the judges get: npm install &amp;&amp; npm run dev → localhost:5173 · tsc and 83 tests green on this commit.</a:t>
             </a:r>
           </a:p>
         </p:txBody>

</xml_diff>

<commit_message>
docs(readme): redesign README with aligned tables, hero banner and verified links
- Rewrite README into 15 numbered sections with a working TOC and aligned tables.
- Add self-contained hero banner (SVG source + 2x PNG) and a real MIT LICENSE.
- Replace the broken ASCII architecture diagram with a Mermaid flowchart.
- Add status-at-a-glance, deploy matrix, stack table and submission pack.
- Recapture all 13 screenshots from the current build (fixed speaker UI).
- Regenerate the 13-slide PPTX/PDF so the deck matches the new screenshots.
- Validate all 57 relative links, 15 TOC anchors, table alignment and HTML balance.
- Quality gate: typecheck 0 errors, 83 tests, build clean, 0 vulnerabilities.
</commit_message>
<xml_diff>
--- a/docs/Kannada-Saathi-Hackathon-Presentation.pptx
+++ b/docs/Kannada-Saathi-Hackathon-Presentation.pptx
@@ -14069,7 +14069,7 @@
       </p:sp>
       <p:pic>
         <p:nvPicPr>
-          <p:cNvPr id="21" name="Picture 20" descr="mobile.png"/>
+          <p:cNvPr id="21" name="Picture 20" descr="mobile-situations.png"/>
           <p:cNvPicPr>
             <a:picLocks noChangeAspect="1"/>
           </p:cNvPicPr>
@@ -14083,8 +14083,8 @@
         </p:blipFill>
         <p:spPr>
           <a:xfrm>
-            <a:off x="9855270" y="3922776"/>
-            <a:ext cx="141083" cy="1783080"/>
+            <a:off x="9513844" y="3922776"/>
+            <a:ext cx="823935" cy="1783080"/>
           </a:xfrm>
           <a:prstGeom prst="rect">
             <a:avLst/>
@@ -14128,7 +14128,7 @@
                 </a:solidFill>
                 <a:latin typeface="Calibri"/>
               </a:rPr>
-              <a:t>390 px · bottom tab bar, one-thumb use</a:t>
+              <a:t>390 px · situation detail, one-thumb use</a:t>
             </a:r>
           </a:p>
         </p:txBody>

</xml_diff>